<commit_message>
Changed false title (from "Monitoring and Logging" to "Security"), fixed some typos
</commit_message>
<xml_diff>
--- a/09-Security/09-Security.pptx
+++ b/09-Security/09-Security.pptx
@@ -346,7 +346,7 @@
           <a:p>
             <a:fld id="{852105B6-D441-4EC0-9FA7-CF26CD0B8EA0}" type="datetimeFigureOut">
               <a:rPr lang="en-US" smtClean="0"/>
-              <a:t>12/21/2017</a:t>
+              <a:t>1/18/2018</a:t>
             </a:fld>
             <a:endParaRPr lang="en-US"/>
           </a:p>
@@ -2829,7 +2829,7 @@
           <a:lstStyle/>
           <a:p>
             <a:r>
-              <a:rPr lang="en-US"/>
+              <a:rPr lang="en-US" dirty="0"/>
               <a:t>Microservices</a:t>
             </a:r>
           </a:p>
@@ -2852,13 +2852,8 @@
           <a:p>
             <a:r>
               <a:rPr lang="de-DE" dirty="0"/>
-              <a:t>Monitoring and </a:t>
-            </a:r>
-            <a:r>
-              <a:rPr lang="de-DE" dirty="0" err="1"/>
-              <a:t>Logging</a:t>
-            </a:r>
-            <a:endParaRPr lang="de-DE" dirty="0"/>
+              <a:t>Security</a:t>
+            </a:r>
           </a:p>
         </p:txBody>
       </p:sp>
@@ -2975,15 +2970,7 @@
           <a:p>
             <a:r>
               <a:rPr lang="en-US" dirty="0"/>
-              <a:t>We won’t look any further as it depends on your use case, technical infrastructure any more how you could implement an API key and there are other ways to solve this which are standardized (</a:t>
-            </a:r>
-            <a:r>
-              <a:rPr lang="en-US" dirty="0" err="1"/>
-              <a:t>Oauth</a:t>
-            </a:r>
-            <a:r>
-              <a:rPr lang="en-US" dirty="0"/>
-              <a:t>/Oauth2, OpenID Connect)</a:t>
+              <a:t>We won’t look any further as it depends on your use case, technical infrastructure any more how you could implement an API key and there are other ways to solve this which are standardized (OAuth/OAuth2, OpenID Connect)</a:t>
             </a:r>
           </a:p>
         </p:txBody>
@@ -9519,12 +9506,8 @@
           </a:p>
           <a:p>
             <a:r>
-              <a:rPr lang="en-US" dirty="0" err="1"/>
-              <a:t>Disadvantes</a:t>
-            </a:r>
-            <a:r>
-              <a:rPr lang="en-US" dirty="0"/>
-              <a:t>:</a:t>
+              <a:rPr lang="en-US" dirty="0"/>
+              <a:t>Disadvantages:</a:t>
             </a:r>
           </a:p>
           <a:p>

</xml_diff>